<commit_message>
Fix pptx: strip float-EMU coords that MS Office rejects
python-pptx's add_connector() and some shape arithmetic leaked
floating-point values (e.g. x="2628900.0") into <a:off>/<a:ext>
attributes. OOXML requires integers there — MS PowerPoint refuses
to open the file with a corruption error. Post-processed the
archive to strip fractional parts on all numeric drawing attrs.

18 attributes fixed on slide 27 (the bipartite-messaging diagram).
</commit_message>
<xml_diff>
--- a/presentation/Graph-of-Shots.pptx
+++ b/presentation/Graph-of-Shots.pptx
@@ -18010,8 +18010,8 @@
         </p:nvCxnSpPr>
         <p:spPr>
           <a:xfrm>
-            <a:off x="8275320" y="2628900.0"/>
-            <a:ext cx="2423160" cy="0.0"/>
+            <a:off x="8275320" y="2628900"/>
+            <a:ext cx="2423160" cy="0"/>
           </a:xfrm>
           <a:prstGeom prst="line">
             <a:avLst/>
@@ -18045,8 +18045,8 @@
         </p:nvCxnSpPr>
         <p:spPr>
           <a:xfrm>
-            <a:off x="8275320" y="2628900.0"/>
-            <a:ext cx="2423160" cy="731520.0"/>
+            <a:off x="8275320" y="2628900"/>
+            <a:ext cx="2423160" cy="731520"/>
           </a:xfrm>
           <a:prstGeom prst="line">
             <a:avLst/>
@@ -18080,8 +18080,8 @@
         </p:nvCxnSpPr>
         <p:spPr>
           <a:xfrm>
-            <a:off x="8275320" y="2628900.0"/>
-            <a:ext cx="2423160" cy="1463040.0"/>
+            <a:off x="8275320" y="2628900"/>
+            <a:ext cx="2423160" cy="1463040"/>
           </a:xfrm>
           <a:prstGeom prst="line">
             <a:avLst/>
@@ -18115,8 +18115,8 @@
         </p:nvCxnSpPr>
         <p:spPr>
           <a:xfrm flipV="1">
-            <a:off x="8275320" y="2628900.0"/>
-            <a:ext cx="2423160" cy="731520.0"/>
+            <a:off x="8275320" y="2628900"/>
+            <a:ext cx="2423160" cy="731520"/>
           </a:xfrm>
           <a:prstGeom prst="line">
             <a:avLst/>
@@ -18150,8 +18150,8 @@
         </p:nvCxnSpPr>
         <p:spPr>
           <a:xfrm>
-            <a:off x="8275320" y="3360420.0"/>
-            <a:ext cx="2423160" cy="0.0"/>
+            <a:off x="8275320" y="3360420"/>
+            <a:ext cx="2423160" cy="0"/>
           </a:xfrm>
           <a:prstGeom prst="line">
             <a:avLst/>
@@ -18185,8 +18185,8 @@
         </p:nvCxnSpPr>
         <p:spPr>
           <a:xfrm>
-            <a:off x="8275320" y="3360420.0"/>
-            <a:ext cx="2423160" cy="731520.0"/>
+            <a:off x="8275320" y="3360420"/>
+            <a:ext cx="2423160" cy="731520"/>
           </a:xfrm>
           <a:prstGeom prst="line">
             <a:avLst/>
@@ -18220,8 +18220,8 @@
         </p:nvCxnSpPr>
         <p:spPr>
           <a:xfrm flipV="1">
-            <a:off x="8275320" y="2628900.0"/>
-            <a:ext cx="2423160" cy="1463040.0"/>
+            <a:off x="8275320" y="2628900"/>
+            <a:ext cx="2423160" cy="1463040"/>
           </a:xfrm>
           <a:prstGeom prst="line">
             <a:avLst/>
@@ -18255,8 +18255,8 @@
         </p:nvCxnSpPr>
         <p:spPr>
           <a:xfrm flipV="1">
-            <a:off x="8275320" y="3360420.0"/>
-            <a:ext cx="2423160" cy="731520.0"/>
+            <a:off x="8275320" y="3360420"/>
+            <a:ext cx="2423160" cy="731520"/>
           </a:xfrm>
           <a:prstGeom prst="line">
             <a:avLst/>
@@ -18290,8 +18290,8 @@
         </p:nvCxnSpPr>
         <p:spPr>
           <a:xfrm>
-            <a:off x="8275320" y="4091940.0"/>
-            <a:ext cx="2423160" cy="0.0"/>
+            <a:off x="8275320" y="4091940"/>
+            <a:ext cx="2423160" cy="0"/>
           </a:xfrm>
           <a:prstGeom prst="line">
             <a:avLst/>

</xml_diff>